<commit_message>
Updated slides and study documents
Removed out of scope contents and unimportant contents.
</commit_message>
<xml_diff>
--- a/yocto_training_all_session_decks/session_decks/D1S1_Welcome.pptx
+++ b/yocto_training_all_session_decks/session_decks/D1S1_Welcome.pptx
@@ -2927,7 +2927,7 @@
           <a:p>
             <a:fld id="{0CEC647C-F50C-4F78-AA33-D7AA6CDA18EE}" type="datetimeFigureOut">
               <a:rPr lang="en-US" smtClean="0"/>
-              <a:t>5/28/2026</a:t>
+              <a:t>6/8/2026</a:t>
             </a:fld>
             <a:endParaRPr lang="en-US"/>
           </a:p>
@@ -3092,7 +3092,7 @@
           <a:p>
             <a:fld id="{3A83341F-E62C-483B-84B4-966F8BE46097}" type="datetimeFigureOut">
               <a:rPr lang="en-US" smtClean="0"/>
-              <a:t>5/28/2026</a:t>
+              <a:t>6/8/2026</a:t>
             </a:fld>
             <a:endParaRPr lang="en-US"/>
           </a:p>
@@ -5306,9 +5306,6 @@
           <a:p>
             <a:r>
               <a:rPr sz="3200" b="1" dirty="0">
-                <a:solidFill>
-                  <a:srgbClr val="CC0066"/>
-                </a:solidFill>
                 <a:latin typeface="Calibri"/>
               </a:rPr>
               <a:t>Session Agenda</a:t>
@@ -5460,10 +5457,7 @@
           <a:lstStyle/>
           <a:p>
             <a:r>
-              <a:rPr sz="3200" b="1">
-                <a:solidFill>
-                  <a:srgbClr val="CC0066"/>
-                </a:solidFill>
+              <a:rPr sz="3200" b="1" dirty="0">
                 <a:latin typeface="Calibri"/>
               </a:rPr>
               <a:t>Course Goals</a:t>
@@ -5480,7 +5474,7 @@
         <p:spPr>
           <a:xfrm>
             <a:off x="822960" y="1417320"/>
-            <a:ext cx="10515600" cy="365760"/>
+            <a:ext cx="10515600" cy="369332"/>
           </a:xfrm>
           <a:prstGeom prst="rect">
             <a:avLst/>
@@ -5495,7 +5489,7 @@
           <a:p>
             <a:pPr algn="l"/>
             <a:r>
-              <a:rPr sz="1500" b="0" i="1">
+              <a:rPr b="0" i="1">
                 <a:solidFill>
                   <a:srgbClr val="666666"/>
                 </a:solidFill>
@@ -5548,7 +5542,7 @@
           <a:p>
             <a:pPr algn="ctr"/>
             <a:r>
-              <a:rPr sz="2200" b="1">
+              <a:rPr sz="2800" b="1">
                 <a:solidFill>
                   <a:srgbClr val="FFFFFF"/>
                 </a:solidFill>
@@ -5568,7 +5562,7 @@
         <p:spPr>
           <a:xfrm>
             <a:off x="1417320" y="1874519"/>
-            <a:ext cx="10058400" cy="320040"/>
+            <a:ext cx="10058400" cy="400110"/>
           </a:xfrm>
           <a:prstGeom prst="rect">
             <a:avLst/>
@@ -5583,7 +5577,7 @@
           <a:p>
             <a:pPr algn="l"/>
             <a:r>
-              <a:rPr sz="1600" b="1" i="0">
+              <a:rPr sz="2000" b="1" i="0">
                 <a:solidFill>
                   <a:srgbClr val="663399"/>
                 </a:solidFill>
@@ -5603,7 +5597,7 @@
         <p:spPr>
           <a:xfrm>
             <a:off x="1417320" y="2185415"/>
-            <a:ext cx="10058400" cy="320040"/>
+            <a:ext cx="10058400" cy="338554"/>
           </a:xfrm>
           <a:prstGeom prst="rect">
             <a:avLst/>
@@ -5618,7 +5612,7 @@
           <a:p>
             <a:pPr algn="l"/>
             <a:r>
-              <a:rPr sz="1300" b="0" i="0">
+              <a:rPr sz="1600" b="0" i="0">
                 <a:solidFill>
                   <a:srgbClr val="333333"/>
                 </a:solidFill>
@@ -5671,7 +5665,7 @@
           <a:p>
             <a:pPr algn="ctr"/>
             <a:r>
-              <a:rPr sz="2200" b="1">
+              <a:rPr sz="2800" b="1">
                 <a:solidFill>
                   <a:srgbClr val="FFFFFF"/>
                 </a:solidFill>
@@ -5691,7 +5685,7 @@
         <p:spPr>
           <a:xfrm>
             <a:off x="1417320" y="2587752"/>
-            <a:ext cx="10058400" cy="320040"/>
+            <a:ext cx="10058400" cy="400110"/>
           </a:xfrm>
           <a:prstGeom prst="rect">
             <a:avLst/>
@@ -5706,7 +5700,7 @@
           <a:p>
             <a:pPr algn="l"/>
             <a:r>
-              <a:rPr sz="1600" b="1" i="0">
+              <a:rPr sz="2000" b="1" i="0">
                 <a:solidFill>
                   <a:srgbClr val="663399"/>
                 </a:solidFill>
@@ -5726,7 +5720,7 @@
         <p:spPr>
           <a:xfrm>
             <a:off x="1417320" y="2898648"/>
-            <a:ext cx="10058400" cy="320040"/>
+            <a:ext cx="10058400" cy="338554"/>
           </a:xfrm>
           <a:prstGeom prst="rect">
             <a:avLst/>
@@ -5741,7 +5735,7 @@
           <a:p>
             <a:pPr algn="l"/>
             <a:r>
-              <a:rPr sz="1300" b="0" i="0">
+              <a:rPr sz="1600" b="0" i="0">
                 <a:solidFill>
                   <a:srgbClr val="333333"/>
                 </a:solidFill>
@@ -5794,7 +5788,7 @@
           <a:p>
             <a:pPr algn="ctr"/>
             <a:r>
-              <a:rPr sz="2200" b="1">
+              <a:rPr sz="2800" b="1">
                 <a:solidFill>
                   <a:srgbClr val="FFFFFF"/>
                 </a:solidFill>
@@ -5814,7 +5808,7 @@
         <p:spPr>
           <a:xfrm>
             <a:off x="1417320" y="3300984"/>
-            <a:ext cx="10058400" cy="320040"/>
+            <a:ext cx="10058400" cy="400110"/>
           </a:xfrm>
           <a:prstGeom prst="rect">
             <a:avLst/>
@@ -5829,7 +5823,7 @@
           <a:p>
             <a:pPr algn="l"/>
             <a:r>
-              <a:rPr sz="1600" b="1" i="0">
+              <a:rPr sz="2000" b="1" i="0">
                 <a:solidFill>
                   <a:srgbClr val="663399"/>
                 </a:solidFill>
@@ -5849,7 +5843,7 @@
         <p:spPr>
           <a:xfrm>
             <a:off x="1417320" y="3611879"/>
-            <a:ext cx="10058400" cy="320040"/>
+            <a:ext cx="10058400" cy="338554"/>
           </a:xfrm>
           <a:prstGeom prst="rect">
             <a:avLst/>
@@ -5864,7 +5858,7 @@
           <a:p>
             <a:pPr algn="l"/>
             <a:r>
-              <a:rPr sz="1300" b="0" i="0" dirty="0">
+              <a:rPr sz="1600" b="0" i="0" dirty="0">
                 <a:solidFill>
                   <a:srgbClr val="333333"/>
                 </a:solidFill>
@@ -5917,7 +5911,7 @@
           <a:p>
             <a:pPr algn="ctr"/>
             <a:r>
-              <a:rPr sz="2200" b="1">
+              <a:rPr sz="2800" b="1">
                 <a:solidFill>
                   <a:srgbClr val="FFFFFF"/>
                 </a:solidFill>
@@ -5937,7 +5931,7 @@
         <p:spPr>
           <a:xfrm>
             <a:off x="1417320" y="4014215"/>
-            <a:ext cx="10058400" cy="320040"/>
+            <a:ext cx="10058400" cy="400110"/>
           </a:xfrm>
           <a:prstGeom prst="rect">
             <a:avLst/>
@@ -5952,7 +5946,7 @@
           <a:p>
             <a:pPr algn="l"/>
             <a:r>
-              <a:rPr sz="1600" b="1" i="0">
+              <a:rPr sz="2000" b="1" i="0">
                 <a:solidFill>
                   <a:srgbClr val="663399"/>
                 </a:solidFill>
@@ -5972,7 +5966,7 @@
         <p:spPr>
           <a:xfrm>
             <a:off x="1417320" y="4325112"/>
-            <a:ext cx="10058400" cy="320040"/>
+            <a:ext cx="10058400" cy="338554"/>
           </a:xfrm>
           <a:prstGeom prst="rect">
             <a:avLst/>
@@ -5987,7 +5981,7 @@
           <a:p>
             <a:pPr algn="l"/>
             <a:r>
-              <a:rPr sz="1300" b="0" i="0">
+              <a:rPr sz="1600" b="0" i="0">
                 <a:solidFill>
                   <a:srgbClr val="333333"/>
                 </a:solidFill>
@@ -6040,7 +6034,7 @@
           <a:p>
             <a:pPr algn="ctr"/>
             <a:r>
-              <a:rPr sz="2200" b="1">
+              <a:rPr sz="2800" b="1">
                 <a:solidFill>
                   <a:srgbClr val="FFFFFF"/>
                 </a:solidFill>
@@ -6060,7 +6054,7 @@
         <p:spPr>
           <a:xfrm>
             <a:off x="1417320" y="4727448"/>
-            <a:ext cx="10058400" cy="320040"/>
+            <a:ext cx="10058400" cy="400110"/>
           </a:xfrm>
           <a:prstGeom prst="rect">
             <a:avLst/>
@@ -6075,14 +6069,47 @@
           <a:p>
             <a:pPr algn="l"/>
             <a:r>
-              <a:rPr sz="1600" b="1" i="0">
+              <a:rPr sz="2000" b="1" i="0" dirty="0">
                 <a:solidFill>
                   <a:srgbClr val="663399"/>
                 </a:solidFill>
                 <a:latin typeface="Calibri"/>
               </a:rPr>
-              <a:t>Read the Yocto docs without fear</a:t>
-            </a:r>
+              <a:t>Read the </a:t>
+            </a:r>
+            <a:r>
+              <a:rPr sz="2000" b="1" i="0" dirty="0" err="1">
+                <a:solidFill>
+                  <a:srgbClr val="663399"/>
+                </a:solidFill>
+                <a:latin typeface="Calibri"/>
+              </a:rPr>
+              <a:t>Yocto</a:t>
+            </a:r>
+            <a:r>
+              <a:rPr sz="2000" b="1" i="0" dirty="0">
+                <a:solidFill>
+                  <a:srgbClr val="663399"/>
+                </a:solidFill>
+                <a:latin typeface="Calibri"/>
+              </a:rPr>
+              <a:t> docs with</a:t>
+            </a:r>
+            <a:r>
+              <a:rPr lang="en-IN" sz="2000" b="1" i="0" dirty="0">
+                <a:solidFill>
+                  <a:srgbClr val="663399"/>
+                </a:solidFill>
+                <a:latin typeface="Calibri"/>
+              </a:rPr>
+              <a:t> confidence</a:t>
+            </a:r>
+            <a:endParaRPr sz="2000" b="1" i="0" dirty="0">
+              <a:solidFill>
+                <a:srgbClr val="663399"/>
+              </a:solidFill>
+              <a:latin typeface="Calibri"/>
+            </a:endParaRPr>
           </a:p>
         </p:txBody>
       </p:sp>
@@ -6095,7 +6122,7 @@
         <p:spPr>
           <a:xfrm>
             <a:off x="1417320" y="5038344"/>
-            <a:ext cx="10058400" cy="320040"/>
+            <a:ext cx="10058400" cy="338554"/>
           </a:xfrm>
           <a:prstGeom prst="rect">
             <a:avLst/>
@@ -6110,7 +6137,7 @@
           <a:p>
             <a:pPr algn="l"/>
             <a:r>
-              <a:rPr sz="1300" b="0" i="0">
+              <a:rPr sz="1600" b="0" i="0">
                 <a:solidFill>
                   <a:srgbClr val="333333"/>
                 </a:solidFill>
@@ -6766,7 +6793,7 @@
               </a:spcAft>
             </a:pPr>
             <a:r>
-              <a:rPr sz="1600" b="0" i="0">
+              <a:rPr sz="1600" b="0" i="0" dirty="0">
                 <a:solidFill>
                   <a:srgbClr val="333333"/>
                 </a:solidFill>
@@ -6782,7 +6809,7 @@
               </a:spcAft>
             </a:pPr>
             <a:r>
-              <a:rPr sz="1600" b="0" i="0">
+              <a:rPr sz="1600" b="0" i="0" dirty="0">
                 <a:solidFill>
                   <a:srgbClr val="333333"/>
                 </a:solidFill>
@@ -6798,13 +6825,22 @@
               </a:spcAft>
             </a:pPr>
             <a:r>
-              <a:rPr sz="1600" b="0" i="0">
+              <a:rPr lang="en-IN" sz="1600" dirty="0">
                 <a:solidFill>
                   <a:srgbClr val="333333"/>
                 </a:solidFill>
                 <a:latin typeface="Calibri"/>
               </a:rPr>
-              <a:t>Two breaks: 15:00 and 15:45</a:t>
+              <a:t>One </a:t>
+            </a:r>
+            <a:r>
+              <a:rPr sz="1600" b="0" i="0" dirty="0">
+                <a:solidFill>
+                  <a:srgbClr val="333333"/>
+                </a:solidFill>
+                <a:latin typeface="Calibri"/>
+              </a:rPr>
+              <a:t>breaks: 15:00</a:t>
             </a:r>
           </a:p>
           <a:p>
@@ -6813,7 +6849,7 @@
                 <a:spcPts val="400"/>
               </a:spcAft>
             </a:pPr>
-            <a:endParaRPr sz="1600" b="0" i="0">
+            <a:endParaRPr sz="1600" b="0" i="0" dirty="0">
               <a:solidFill>
                 <a:srgbClr val="333333"/>
               </a:solidFill>
@@ -6827,7 +6863,7 @@
               </a:spcAft>
             </a:pPr>
             <a:r>
-              <a:rPr sz="1600" b="0" i="0">
+              <a:rPr sz="1600" b="0" i="0" dirty="0">
                 <a:solidFill>
                   <a:srgbClr val="333333"/>
                 </a:solidFill>
@@ -6879,10 +6915,7 @@
           <a:lstStyle/>
           <a:p>
             <a:r>
-              <a:rPr sz="3200" b="1">
-                <a:solidFill>
-                  <a:srgbClr val="CC0066"/>
-                </a:solidFill>
+              <a:rPr sz="3200" b="1" dirty="0">
                 <a:latin typeface="Calibri"/>
               </a:rPr>
               <a:t>Ground Rules</a:t>
@@ -6934,7 +6967,7 @@
         <p:spPr>
           <a:xfrm>
             <a:off x="822960" y="1874519"/>
-            <a:ext cx="10515600" cy="2975173"/>
+            <a:ext cx="10515600" cy="2215991"/>
           </a:xfrm>
           <a:prstGeom prst="rect">
             <a:avLst/>
@@ -7017,14 +7050,20 @@
               </a:spcAft>
             </a:pPr>
             <a:r>
-              <a:rPr sz="2000" b="1" i="0" dirty="0">
+              <a:rPr lang="en-IN" sz="2000" b="1" dirty="0">
                 <a:solidFill>
                   <a:srgbClr val="CC0066"/>
                 </a:solidFill>
                 <a:latin typeface="Calibri"/>
               </a:rPr>
-              <a:t>Don't suffer in silence with broken environments</a:t>
-            </a:r>
+              <a:t>Get support instead of struggling</a:t>
+            </a:r>
+            <a:endParaRPr sz="2000" b="1" dirty="0">
+              <a:solidFill>
+                <a:srgbClr val="CC0066"/>
+              </a:solidFill>
+              <a:latin typeface="Calibri"/>
+            </a:endParaRPr>
           </a:p>
           <a:p>
             <a:pPr>
@@ -7040,38 +7079,6 @@
                 <a:latin typeface="Calibri"/>
               </a:rPr>
               <a:t>Builds break. Raise a hand. We have spare states ready to restore from.</a:t>
-            </a:r>
-          </a:p>
-          <a:p>
-            <a:pPr>
-              <a:spcAft>
-                <a:spcPts val="400"/>
-              </a:spcAft>
-            </a:pPr>
-            <a:r>
-              <a:rPr sz="2000" b="1" i="0" dirty="0">
-                <a:solidFill>
-                  <a:srgbClr val="CC0066"/>
-                </a:solidFill>
-                <a:latin typeface="Calibri"/>
-              </a:rPr>
-              <a:t>Phones on silent, laptops up</a:t>
-            </a:r>
-          </a:p>
-          <a:p>
-            <a:pPr>
-              <a:spcAft>
-                <a:spcPts val="400"/>
-              </a:spcAft>
-            </a:pPr>
-            <a:r>
-              <a:rPr sz="1600" b="0" i="0" dirty="0">
-                <a:solidFill>
-                  <a:srgbClr val="333333"/>
-                </a:solidFill>
-                <a:latin typeface="Calibri"/>
-              </a:rPr>
-              <a:t>The course is interactive — you cannot follow if your laptop is closed.</a:t>
             </a:r>
           </a:p>
         </p:txBody>
@@ -7117,10 +7124,7 @@
           <a:lstStyle/>
           <a:p>
             <a:r>
-              <a:rPr sz="3200" b="1">
-                <a:solidFill>
-                  <a:srgbClr val="CC0066"/>
-                </a:solidFill>
+              <a:rPr sz="3200" b="1" dirty="0">
                 <a:latin typeface="Calibri"/>
               </a:rPr>
               <a:t>Environment Quick Check</a:t>
@@ -7137,7 +7141,7 @@
         <p:spPr>
           <a:xfrm>
             <a:off x="822960" y="1417320"/>
-            <a:ext cx="10515600" cy="365760"/>
+            <a:ext cx="10515600" cy="338554"/>
           </a:xfrm>
           <a:prstGeom prst="rect">
             <a:avLst/>
@@ -7152,7 +7156,7 @@
           <a:p>
             <a:pPr algn="l"/>
             <a:r>
-              <a:rPr sz="1500" b="0" i="1">
+              <a:rPr sz="1600" b="0" i="1" dirty="0">
                 <a:solidFill>
                   <a:srgbClr val="666666"/>
                 </a:solidFill>

</xml_diff>

<commit_message>
Added Day 1 study materials
Session wise materials added
</commit_message>
<xml_diff>
--- a/yocto_training_all_session_decks/session_decks/D1S1_Welcome.pptx
+++ b/yocto_training_all_session_decks/session_decks/D1S1_Welcome.pptx
@@ -2927,7 +2927,7 @@
           <a:p>
             <a:fld id="{0CEC647C-F50C-4F78-AA33-D7AA6CDA18EE}" type="datetimeFigureOut">
               <a:rPr lang="en-US" smtClean="0"/>
-              <a:t>6/8/2026</a:t>
+              <a:t>6/9/2026</a:t>
             </a:fld>
             <a:endParaRPr lang="en-US"/>
           </a:p>
@@ -3092,7 +3092,7 @@
           <a:p>
             <a:fld id="{3A83341F-E62C-483B-84B4-966F8BE46097}" type="datetimeFigureOut">
               <a:rPr lang="en-US" smtClean="0"/>
-              <a:t>6/8/2026</a:t>
+              <a:t>6/9/2026</a:t>
             </a:fld>
             <a:endParaRPr lang="en-US"/>
           </a:p>

</xml_diff>